<commit_message>
Présentation : retire toute mention CMI / PayZone
- HTML : "paiement CMI / PayZone" -> "conventions marocaines".
- PPTX : bloc "CMI / PayZone" -> "Abonnements" ; bas de page sans "paiement CMI".

Co-Authored-By: Claude Opus 4.8 <noreply@anthropic.com>
Claude-Session: https://claude.ai/code/session_01V3WwFfquZc9gn83p28XPma
</commit_message>
<xml_diff>
--- a/marketing/QCG_Markets-schema.pptx
+++ b/marketing/QCG_Markets-schema.pptx
@@ -1326,7 +1326,7 @@
                 <a:ea typeface="Calibri" pitchFamily="34" charset="-122"/>
                 <a:cs typeface="Calibri" pitchFamily="34" charset="-120"/>
               </a:rPr>
-              <a:t>Bourse de Casablanca · BKAM · AMMC · paiement CMI (MAD)</a:t>
+              <a:t>Bourse de Casablanca · BKAM · AMMC · dirham (MAD)</a:t>
             </a:r>
             <a:endParaRPr lang="en-US" sz="1200" dirty="0"/>
           </a:p>
@@ -2614,7 +2614,7 @@
                 <a:ea typeface="Century Schoolbook" pitchFamily="34" charset="-122"/>
                 <a:cs typeface="Century Schoolbook" pitchFamily="34" charset="-120"/>
               </a:rPr>
-              <a:t>CMI / PayZone</a:t>
+              <a:t>Abonnements</a:t>
             </a:r>
             <a:endParaRPr lang="en-US" sz="1300" dirty="0"/>
           </a:p>
@@ -2656,7 +2656,7 @@
                 <a:ea typeface="Calibri" pitchFamily="34" charset="-122"/>
                 <a:cs typeface="Calibri" pitchFamily="34" charset="-120"/>
               </a:rPr>
-              <a:t>Paiement récurrent en MAD</a:t>
+              <a:t>Facturation en dirham (MAD)</a:t>
             </a:r>
             <a:endParaRPr lang="en-US" sz="950" dirty="0"/>
           </a:p>

</xml_diff>